<commit_message>
Update SIH deck with new team details and fresh live screenshots
Team Name/ID changed to Nexus2.O / 164739 per the updated submission
details. Re-captured both product screenshots from the live site
(dashboard and actor-profile evidence) since the prior crops were two
weeks stale -- the new actor-profile capture also includes the
confidence badge and per-signal percentage bars that were below the
fold in the old one. Sizing math now derives from named aspect-ratio
constants instead of inline literals, since the new screenshots have
different proportions than the old ones.

Co-Authored-By: Claude Sonnet 5 <noreply@anthropic.com>
Claude-Session: https://claude.ai/code/session_01QM2N4PHw8FCDhcC8T7BiAq
</commit_message>
<xml_diff>
--- a/presentation/dist/Argus_SIH2026_Idea_Submission.pptx
+++ b/presentation/dist/Argus_SIH2026_Idea_Submission.pptx
@@ -6155,7 +6155,7 @@
                 </a:solidFill>
                 <a:latin typeface="Arial"/>
               </a:rPr>
-              <a:t>Team Nexus  •  T141</a:t>
+              <a:t>Nexus2.O  •  164739</a:t>
             </a:r>
           </a:p>
         </p:txBody>
@@ -7655,7 +7655,7 @@
       </p:sp>
       <p:pic>
         <p:nvPicPr>
-          <p:cNvPr id="15389" name="Picture 15388" descr="dashboard_crop3.jpg"/>
+          <p:cNvPr id="15389" name="Picture 15388" descr="dashboard_crop_new.jpg"/>
           <p:cNvPicPr>
             <a:picLocks noChangeAspect="1"/>
           </p:cNvPicPr>
@@ -7670,7 +7670,7 @@
         <p:spPr>
           <a:xfrm>
             <a:off x="8458200" y="2359152"/>
-            <a:ext cx="3182112" cy="1015027"/>
+            <a:ext cx="3182112" cy="580861"/>
           </a:xfrm>
           <a:prstGeom prst="rect">
             <a:avLst/>
@@ -7690,7 +7690,7 @@
         </p:nvSpPr>
         <p:spPr>
           <a:xfrm>
-            <a:off x="8549640" y="3538771"/>
+            <a:off x="8549640" y="3104605"/>
             <a:ext cx="2999232" cy="292608"/>
           </a:xfrm>
           <a:prstGeom prst="rect">
@@ -7733,7 +7733,7 @@
         </p:nvSpPr>
         <p:spPr>
           <a:xfrm>
-            <a:off x="8549640" y="3849667"/>
+            <a:off x="8549640" y="3415501"/>
             <a:ext cx="2999232" cy="292608"/>
           </a:xfrm>
           <a:prstGeom prst="rect">
@@ -7776,7 +7776,7 @@
         </p:nvSpPr>
         <p:spPr>
           <a:xfrm>
-            <a:off x="8549640" y="4160563"/>
+            <a:off x="8549640" y="3726397"/>
             <a:ext cx="2999232" cy="292608"/>
           </a:xfrm>
           <a:prstGeom prst="rect">
@@ -7819,7 +7819,7 @@
         </p:nvSpPr>
         <p:spPr>
           <a:xfrm>
-            <a:off x="8549640" y="4471459"/>
+            <a:off x="8549640" y="4037293"/>
             <a:ext cx="2999232" cy="292608"/>
           </a:xfrm>
           <a:prstGeom prst="rect">
@@ -12033,7 +12033,7 @@
       </p:sp>
       <p:pic>
         <p:nvPicPr>
-          <p:cNvPr id="17440" name="Picture 17439" descr="actor_profile_crop.jpg"/>
+          <p:cNvPr id="17440" name="Picture 17439" descr="actor_profile_new.jpg"/>
           <p:cNvPicPr>
             <a:picLocks noChangeAspect="1"/>
           </p:cNvPicPr>
@@ -12047,8 +12047,8 @@
         </p:blipFill>
         <p:spPr>
           <a:xfrm>
-            <a:off x="8330184" y="2181285"/>
-            <a:ext cx="3312871" cy="1453013"/>
+            <a:off x="8538696" y="2153412"/>
+            <a:ext cx="2895845" cy="1508760"/>
           </a:xfrm>
           <a:prstGeom prst="rect">
             <a:avLst/>
@@ -15489,7 +15489,7 @@
       </p:sp>
       <p:pic>
         <p:nvPicPr>
-          <p:cNvPr id="17431" name="Picture 17430" descr="dashboard_crop3.jpg"/>
+          <p:cNvPr id="17431" name="Picture 17430" descr="dashboard_crop_new.jpg"/>
           <p:cNvPicPr>
             <a:picLocks noChangeAspect="1"/>
           </p:cNvPicPr>
@@ -15503,8 +15503,8 @@
         </p:blipFill>
         <p:spPr>
           <a:xfrm>
-            <a:off x="3346018" y="3474720"/>
-            <a:ext cx="7739938" cy="2468880"/>
+            <a:off x="2788920" y="3901044"/>
+            <a:ext cx="8854135" cy="1616230"/>
           </a:xfrm>
           <a:prstGeom prst="rect">
             <a:avLst/>

</xml_diff>

<commit_message>
Fill the template's top-left team-name slot instead of deleting it
Confirmed against the official SIH template: every content slide has
an Oval shape at this exact top-left spot holding placeholder text
"Your Team Name" -- a real template field, not decoration. It had
been deleted entirely because clearing its text left a bare stroke
outline. Now: the corner circle is shrunk (2.6in -> 1.9in) to clear
both the header bar and title row, and a proper white badge showing
the actual team name sits in that freed space on every slide.

Co-Authored-By: Claude Sonnet 5 <noreply@anthropic.com>
Claude-Session: https://claude.ai/code/session_01QM2N4PHw8FCDhcC8T7BiAq
</commit_message>
<xml_diff>
--- a/presentation/dist/Argus_SIH2026_Idea_Submission.pptx
+++ b/presentation/dist/Argus_SIH2026_Idea_Submission.pptx
@@ -5651,8 +5651,8 @@
         </p:nvSpPr>
         <p:spPr>
           <a:xfrm>
-            <a:off x="-1188720" y="-1188720"/>
-            <a:ext cx="2377440" cy="2377440"/>
+            <a:off x="-868680" y="-868680"/>
+            <a:ext cx="1737360" cy="1737360"/>
           </a:xfrm>
           <a:prstGeom prst="ellipse">
             <a:avLst/>
@@ -5689,7 +5689,62 @@
       </p:sp>
       <p:sp>
         <p:nvSpPr>
-          <p:cNvPr id="39" name="Rectangle 38"/>
+          <p:cNvPr id="39" name="Rounded Rectangle 38"/>
+          <p:cNvSpPr/>
+          <p:nvPr/>
+        </p:nvSpPr>
+        <p:spPr>
+          <a:xfrm>
+            <a:off x="91440" y="292608"/>
+            <a:ext cx="1207008" cy="329184"/>
+          </a:xfrm>
+          <a:prstGeom prst="roundRect">
+            <a:avLst/>
+          </a:prstGeom>
+          <a:solidFill>
+            <a:srgbClr val="FFFFFF"/>
+          </a:solidFill>
+          <a:ln w="12700">
+            <a:solidFill>
+              <a:srgbClr val="FFFFFF"/>
+            </a:solidFill>
+          </a:ln>
+          <a:effectLst/>
+        </p:spPr>
+        <p:style>
+          <a:lnRef idx="1">
+            <a:schemeClr val="accent1"/>
+          </a:lnRef>
+          <a:fillRef idx="3">
+            <a:schemeClr val="accent1"/>
+          </a:fillRef>
+          <a:effectRef idx="2">
+            <a:schemeClr val="accent1"/>
+          </a:effectRef>
+          <a:fontRef idx="minor">
+            <a:schemeClr val="lt1"/>
+          </a:fontRef>
+        </p:style>
+        <p:txBody>
+          <a:bodyPr rtlCol="0" anchor="ctr" lIns="54864" rIns="54864" tIns="0" bIns="0"/>
+          <a:lstStyle/>
+          <a:p>
+            <a:pPr algn="ctr"/>
+            <a:r>
+              <a:rPr sz="1200" b="1">
+                <a:solidFill>
+                  <a:srgbClr val="422F6C"/>
+                </a:solidFill>
+                <a:latin typeface="Arial"/>
+              </a:rPr>
+              <a:t>Nexus2.O</a:t>
+            </a:r>
+          </a:p>
+        </p:txBody>
+      </p:sp>
+      <p:sp>
+        <p:nvSpPr>
+          <p:cNvPr id="40" name="Rectangle 39"/>
           <p:cNvSpPr/>
           <p:nvPr/>
         </p:nvSpPr>
@@ -5742,7 +5797,7 @@
       </p:sp>
       <p:sp>
         <p:nvSpPr>
-          <p:cNvPr id="40" name="Oval 39"/>
+          <p:cNvPr id="41" name="Oval 40"/>
           <p:cNvSpPr/>
           <p:nvPr/>
         </p:nvSpPr>
@@ -5786,7 +5841,7 @@
       </p:sp>
       <p:sp>
         <p:nvSpPr>
-          <p:cNvPr id="41" name="TextBox 40"/>
+          <p:cNvPr id="42" name="TextBox 41"/>
           <p:cNvSpPr txBox="1"/>
           <p:nvPr/>
         </p:nvSpPr>
@@ -5826,7 +5881,7 @@
       </p:sp>
       <p:sp>
         <p:nvSpPr>
-          <p:cNvPr id="42" name="TextBox 41"/>
+          <p:cNvPr id="43" name="TextBox 42"/>
           <p:cNvSpPr txBox="1"/>
           <p:nvPr/>
         </p:nvSpPr>
@@ -5860,7 +5915,7 @@
       </p:sp>
       <p:sp>
         <p:nvSpPr>
-          <p:cNvPr id="43" name="TextBox 42"/>
+          <p:cNvPr id="44" name="TextBox 43"/>
           <p:cNvSpPr txBox="1"/>
           <p:nvPr/>
         </p:nvSpPr>
@@ -5894,7 +5949,7 @@
       </p:sp>
       <p:sp>
         <p:nvSpPr>
-          <p:cNvPr id="44" name="Rounded Rectangle 43"/>
+          <p:cNvPr id="45" name="Rounded Rectangle 44"/>
           <p:cNvSpPr/>
           <p:nvPr/>
         </p:nvSpPr>
@@ -5961,7 +6016,7 @@
       </p:sp>
       <p:sp>
         <p:nvSpPr>
-          <p:cNvPr id="45" name="Rounded Rectangle 44"/>
+          <p:cNvPr id="46" name="Rounded Rectangle 45"/>
           <p:cNvSpPr/>
           <p:nvPr/>
         </p:nvSpPr>
@@ -6028,7 +6083,7 @@
       </p:sp>
       <p:sp>
         <p:nvSpPr>
-          <p:cNvPr id="46" name="Rounded Rectangle 45"/>
+          <p:cNvPr id="47" name="Rounded Rectangle 46"/>
           <p:cNvSpPr/>
           <p:nvPr/>
         </p:nvSpPr>
@@ -6095,7 +6150,7 @@
       </p:sp>
       <p:sp>
         <p:nvSpPr>
-          <p:cNvPr id="47" name="Rounded Rectangle 46"/>
+          <p:cNvPr id="48" name="Rounded Rectangle 47"/>
           <p:cNvSpPr/>
           <p:nvPr/>
         </p:nvSpPr>
@@ -6162,7 +6217,7 @@
       </p:sp>
       <p:cxnSp>
         <p:nvCxnSpPr>
-          <p:cNvPr id="48" name="Connector 47"/>
+          <p:cNvPr id="49" name="Connector 48"/>
           <p:cNvCxnSpPr/>
           <p:nvPr/>
         </p:nvCxnSpPr>
@@ -6197,7 +6252,7 @@
       </p:cxnSp>
       <p:sp>
         <p:nvSpPr>
-          <p:cNvPr id="49" name="TextBox 48"/>
+          <p:cNvPr id="50" name="TextBox 49"/>
           <p:cNvSpPr txBox="1"/>
           <p:nvPr/>
         </p:nvSpPr>
@@ -6489,8 +6544,8 @@
         </p:nvSpPr>
         <p:spPr>
           <a:xfrm>
-            <a:off x="-1188720" y="-1188720"/>
-            <a:ext cx="2377440" cy="2377440"/>
+            <a:off x="-868680" y="-868680"/>
+            <a:ext cx="1737360" cy="1737360"/>
           </a:xfrm>
           <a:prstGeom prst="ellipse">
             <a:avLst/>
@@ -6527,7 +6582,62 @@
       </p:sp>
       <p:sp>
         <p:nvSpPr>
-          <p:cNvPr id="15364" name="Rectangle 15363"/>
+          <p:cNvPr id="15364" name="Rounded Rectangle 15363"/>
+          <p:cNvSpPr/>
+          <p:nvPr/>
+        </p:nvSpPr>
+        <p:spPr>
+          <a:xfrm>
+            <a:off x="91440" y="292608"/>
+            <a:ext cx="1207008" cy="329184"/>
+          </a:xfrm>
+          <a:prstGeom prst="roundRect">
+            <a:avLst/>
+          </a:prstGeom>
+          <a:solidFill>
+            <a:srgbClr val="FFFFFF"/>
+          </a:solidFill>
+          <a:ln w="12700">
+            <a:solidFill>
+              <a:srgbClr val="FFFFFF"/>
+            </a:solidFill>
+          </a:ln>
+          <a:effectLst/>
+        </p:spPr>
+        <p:style>
+          <a:lnRef idx="1">
+            <a:schemeClr val="accent1"/>
+          </a:lnRef>
+          <a:fillRef idx="3">
+            <a:schemeClr val="accent1"/>
+          </a:fillRef>
+          <a:effectRef idx="2">
+            <a:schemeClr val="accent1"/>
+          </a:effectRef>
+          <a:fontRef idx="minor">
+            <a:schemeClr val="lt1"/>
+          </a:fontRef>
+        </p:style>
+        <p:txBody>
+          <a:bodyPr rtlCol="0" anchor="ctr" lIns="54864" rIns="54864" tIns="0" bIns="0"/>
+          <a:lstStyle/>
+          <a:p>
+            <a:pPr algn="ctr"/>
+            <a:r>
+              <a:rPr sz="1200" b="1">
+                <a:solidFill>
+                  <a:srgbClr val="422F6C"/>
+                </a:solidFill>
+                <a:latin typeface="Arial"/>
+              </a:rPr>
+              <a:t>Nexus2.O</a:t>
+            </a:r>
+          </a:p>
+        </p:txBody>
+      </p:sp>
+      <p:sp>
+        <p:nvSpPr>
+          <p:cNvPr id="15365" name="Rectangle 15364"/>
           <p:cNvSpPr/>
           <p:nvPr/>
         </p:nvSpPr>
@@ -6580,7 +6690,7 @@
       </p:sp>
       <p:sp>
         <p:nvSpPr>
-          <p:cNvPr id="15365" name="TextBox 15364"/>
+          <p:cNvPr id="15366" name="TextBox 15365"/>
           <p:cNvSpPr txBox="1"/>
           <p:nvPr/>
         </p:nvSpPr>
@@ -6614,7 +6724,7 @@
       </p:sp>
       <p:sp>
         <p:nvSpPr>
-          <p:cNvPr id="15366" name="TextBox 15365"/>
+          <p:cNvPr id="15367" name="TextBox 15366"/>
           <p:cNvSpPr txBox="1"/>
           <p:nvPr/>
         </p:nvSpPr>
@@ -6649,7 +6759,7 @@
       </p:sp>
       <p:sp>
         <p:nvSpPr>
-          <p:cNvPr id="15367" name="Oval 15366"/>
+          <p:cNvPr id="15368" name="Oval 15367"/>
           <p:cNvSpPr/>
           <p:nvPr/>
         </p:nvSpPr>
@@ -6693,7 +6803,7 @@
       </p:sp>
       <p:sp>
         <p:nvSpPr>
-          <p:cNvPr id="15368" name="Rounded Rectangle 15367"/>
+          <p:cNvPr id="15369" name="Rounded Rectangle 15368"/>
           <p:cNvSpPr/>
           <p:nvPr/>
         </p:nvSpPr>
@@ -6746,7 +6856,7 @@
       </p:sp>
       <p:sp>
         <p:nvSpPr>
-          <p:cNvPr id="15369" name="Rounded Rectangle 15368"/>
+          <p:cNvPr id="15370" name="Rounded Rectangle 15369"/>
           <p:cNvSpPr/>
           <p:nvPr/>
         </p:nvSpPr>
@@ -6792,7 +6902,7 @@
       </p:sp>
       <p:sp>
         <p:nvSpPr>
-          <p:cNvPr id="15370" name="TextBox 15369"/>
+          <p:cNvPr id="15371" name="TextBox 15370"/>
           <p:cNvSpPr txBox="1"/>
           <p:nvPr/>
         </p:nvSpPr>
@@ -6835,7 +6945,7 @@
       </p:sp>
       <p:sp>
         <p:nvSpPr>
-          <p:cNvPr id="15371" name="TextBox 15370"/>
+          <p:cNvPr id="15372" name="TextBox 15371"/>
           <p:cNvSpPr txBox="1"/>
           <p:nvPr/>
         </p:nvSpPr>
@@ -6878,7 +6988,7 @@
       </p:sp>
       <p:sp>
         <p:nvSpPr>
-          <p:cNvPr id="15372" name="TextBox 15371"/>
+          <p:cNvPr id="15373" name="TextBox 15372"/>
           <p:cNvSpPr txBox="1"/>
           <p:nvPr/>
         </p:nvSpPr>
@@ -6921,7 +7031,7 @@
       </p:sp>
       <p:sp>
         <p:nvSpPr>
-          <p:cNvPr id="15373" name="TextBox 15372"/>
+          <p:cNvPr id="15374" name="TextBox 15373"/>
           <p:cNvSpPr txBox="1"/>
           <p:nvPr/>
         </p:nvSpPr>
@@ -6964,7 +7074,7 @@
       </p:sp>
       <p:sp>
         <p:nvSpPr>
-          <p:cNvPr id="15374" name="TextBox 15373"/>
+          <p:cNvPr id="15375" name="TextBox 15374"/>
           <p:cNvSpPr txBox="1"/>
           <p:nvPr/>
         </p:nvSpPr>
@@ -7007,7 +7117,7 @@
       </p:sp>
       <p:sp>
         <p:nvSpPr>
-          <p:cNvPr id="15375" name="Right Arrow 15374"/>
+          <p:cNvPr id="15376" name="Right Arrow 15375"/>
           <p:cNvSpPr/>
           <p:nvPr/>
         </p:nvSpPr>
@@ -7051,7 +7161,7 @@
       </p:sp>
       <p:sp>
         <p:nvSpPr>
-          <p:cNvPr id="15376" name="TextBox 15375"/>
+          <p:cNvPr id="15377" name="TextBox 15376"/>
           <p:cNvSpPr txBox="1"/>
           <p:nvPr/>
         </p:nvSpPr>
@@ -7086,7 +7196,7 @@
       </p:sp>
       <p:sp>
         <p:nvSpPr>
-          <p:cNvPr id="15377" name="Rounded Rectangle 15376"/>
+          <p:cNvPr id="15378" name="Rounded Rectangle 15377"/>
           <p:cNvSpPr/>
           <p:nvPr/>
         </p:nvSpPr>
@@ -7130,7 +7240,7 @@
       </p:sp>
       <p:sp>
         <p:nvSpPr>
-          <p:cNvPr id="15378" name="Oval 15377"/>
+          <p:cNvPr id="15379" name="Oval 15378"/>
           <p:cNvSpPr/>
           <p:nvPr/>
         </p:nvSpPr>
@@ -7183,7 +7293,7 @@
       </p:sp>
       <p:sp>
         <p:nvSpPr>
-          <p:cNvPr id="15379" name="TextBox 15378"/>
+          <p:cNvPr id="15380" name="TextBox 15379"/>
           <p:cNvSpPr txBox="1"/>
           <p:nvPr/>
         </p:nvSpPr>
@@ -7228,7 +7338,7 @@
       </p:sp>
       <p:sp>
         <p:nvSpPr>
-          <p:cNvPr id="15380" name="Rounded Rectangle 15379"/>
+          <p:cNvPr id="15381" name="Rounded Rectangle 15380"/>
           <p:cNvSpPr/>
           <p:nvPr/>
         </p:nvSpPr>
@@ -7272,7 +7382,7 @@
       </p:sp>
       <p:sp>
         <p:nvSpPr>
-          <p:cNvPr id="15381" name="Oval 15380"/>
+          <p:cNvPr id="15382" name="Oval 15381"/>
           <p:cNvSpPr/>
           <p:nvPr/>
         </p:nvSpPr>
@@ -7325,7 +7435,7 @@
       </p:sp>
       <p:sp>
         <p:nvSpPr>
-          <p:cNvPr id="15382" name="TextBox 15381"/>
+          <p:cNvPr id="15383" name="TextBox 15382"/>
           <p:cNvSpPr txBox="1"/>
           <p:nvPr/>
         </p:nvSpPr>
@@ -7370,7 +7480,7 @@
       </p:sp>
       <p:sp>
         <p:nvSpPr>
-          <p:cNvPr id="15383" name="Rounded Rectangle 15382"/>
+          <p:cNvPr id="15384" name="Rounded Rectangle 15383"/>
           <p:cNvSpPr/>
           <p:nvPr/>
         </p:nvSpPr>
@@ -7414,7 +7524,7 @@
       </p:sp>
       <p:sp>
         <p:nvSpPr>
-          <p:cNvPr id="15384" name="Oval 15383"/>
+          <p:cNvPr id="15385" name="Oval 15384"/>
           <p:cNvSpPr/>
           <p:nvPr/>
         </p:nvSpPr>
@@ -7467,7 +7577,7 @@
       </p:sp>
       <p:sp>
         <p:nvSpPr>
-          <p:cNvPr id="15385" name="TextBox 15384"/>
+          <p:cNvPr id="15386" name="TextBox 15385"/>
           <p:cNvSpPr txBox="1"/>
           <p:nvPr/>
         </p:nvSpPr>
@@ -7512,7 +7622,7 @@
       </p:sp>
       <p:sp>
         <p:nvSpPr>
-          <p:cNvPr id="15386" name="Right Arrow 15385"/>
+          <p:cNvPr id="15387" name="Right Arrow 15386"/>
           <p:cNvSpPr/>
           <p:nvPr/>
         </p:nvSpPr>
@@ -7556,7 +7666,7 @@
       </p:sp>
       <p:sp>
         <p:nvSpPr>
-          <p:cNvPr id="15387" name="Rounded Rectangle 15386"/>
+          <p:cNvPr id="15388" name="Rounded Rectangle 15387"/>
           <p:cNvSpPr/>
           <p:nvPr/>
         </p:nvSpPr>
@@ -7609,7 +7719,7 @@
       </p:sp>
       <p:sp>
         <p:nvSpPr>
-          <p:cNvPr id="15388" name="Rounded Rectangle 15387"/>
+          <p:cNvPr id="15389" name="Rounded Rectangle 15388"/>
           <p:cNvSpPr/>
           <p:nvPr/>
         </p:nvSpPr>
@@ -7655,7 +7765,7 @@
       </p:sp>
       <p:pic>
         <p:nvPicPr>
-          <p:cNvPr id="15389" name="Picture 15388" descr="dashboard_crop_new.jpg"/>
+          <p:cNvPr id="15390" name="Picture 15389" descr="dashboard_crop_new.jpg"/>
           <p:cNvPicPr>
             <a:picLocks noChangeAspect="1"/>
           </p:cNvPicPr>
@@ -7684,7 +7794,7 @@
       </p:pic>
       <p:sp>
         <p:nvSpPr>
-          <p:cNvPr id="15390" name="TextBox 15389"/>
+          <p:cNvPr id="15391" name="TextBox 15390"/>
           <p:cNvSpPr txBox="1"/>
           <p:nvPr/>
         </p:nvSpPr>
@@ -7727,7 +7837,7 @@
       </p:sp>
       <p:sp>
         <p:nvSpPr>
-          <p:cNvPr id="15391" name="TextBox 15390"/>
+          <p:cNvPr id="15392" name="TextBox 15391"/>
           <p:cNvSpPr txBox="1"/>
           <p:nvPr/>
         </p:nvSpPr>
@@ -7770,7 +7880,7 @@
       </p:sp>
       <p:sp>
         <p:nvSpPr>
-          <p:cNvPr id="15392" name="TextBox 15391"/>
+          <p:cNvPr id="15393" name="TextBox 15392"/>
           <p:cNvSpPr txBox="1"/>
           <p:nvPr/>
         </p:nvSpPr>
@@ -7813,7 +7923,7 @@
       </p:sp>
       <p:sp>
         <p:nvSpPr>
-          <p:cNvPr id="15393" name="TextBox 15392"/>
+          <p:cNvPr id="15394" name="TextBox 15393"/>
           <p:cNvSpPr txBox="1"/>
           <p:nvPr/>
         </p:nvSpPr>
@@ -7856,7 +7966,7 @@
       </p:sp>
       <p:sp>
         <p:nvSpPr>
-          <p:cNvPr id="15394" name="Rounded Rectangle 15393"/>
+          <p:cNvPr id="15395" name="Rounded Rectangle 15394"/>
           <p:cNvSpPr/>
           <p:nvPr/>
         </p:nvSpPr>
@@ -7900,7 +8010,7 @@
       </p:sp>
       <p:sp>
         <p:nvSpPr>
-          <p:cNvPr id="15395" name="Rounded Rectangle 15394"/>
+          <p:cNvPr id="15396" name="Rounded Rectangle 15395"/>
           <p:cNvSpPr/>
           <p:nvPr/>
         </p:nvSpPr>
@@ -7953,7 +8063,7 @@
       </p:sp>
       <p:sp>
         <p:nvSpPr>
-          <p:cNvPr id="15396" name="Right Arrow 15395"/>
+          <p:cNvPr id="15397" name="Right Arrow 15396"/>
           <p:cNvSpPr/>
           <p:nvPr/>
         </p:nvSpPr>
@@ -7997,7 +8107,7 @@
       </p:sp>
       <p:sp>
         <p:nvSpPr>
-          <p:cNvPr id="15397" name="Rounded Rectangle 15396"/>
+          <p:cNvPr id="15398" name="Rounded Rectangle 15397"/>
           <p:cNvSpPr/>
           <p:nvPr/>
         </p:nvSpPr>
@@ -8050,7 +8160,7 @@
       </p:sp>
       <p:sp>
         <p:nvSpPr>
-          <p:cNvPr id="15398" name="Right Arrow 15397"/>
+          <p:cNvPr id="15399" name="Right Arrow 15398"/>
           <p:cNvSpPr/>
           <p:nvPr/>
         </p:nvSpPr>
@@ -8094,7 +8204,7 @@
       </p:sp>
       <p:sp>
         <p:nvSpPr>
-          <p:cNvPr id="15399" name="Rounded Rectangle 15398"/>
+          <p:cNvPr id="15400" name="Rounded Rectangle 15399"/>
           <p:cNvSpPr/>
           <p:nvPr/>
         </p:nvSpPr>
@@ -8147,7 +8257,7 @@
       </p:sp>
       <p:sp>
         <p:nvSpPr>
-          <p:cNvPr id="15400" name="Right Arrow 15399"/>
+          <p:cNvPr id="15401" name="Right Arrow 15400"/>
           <p:cNvSpPr/>
           <p:nvPr/>
         </p:nvSpPr>
@@ -8191,7 +8301,7 @@
       </p:sp>
       <p:sp>
         <p:nvSpPr>
-          <p:cNvPr id="15401" name="Rounded Rectangle 15400"/>
+          <p:cNvPr id="15402" name="Rounded Rectangle 15401"/>
           <p:cNvSpPr/>
           <p:nvPr/>
         </p:nvSpPr>
@@ -8244,7 +8354,7 @@
       </p:sp>
       <p:sp>
         <p:nvSpPr>
-          <p:cNvPr id="15402" name="Right Arrow 15401"/>
+          <p:cNvPr id="15403" name="Right Arrow 15402"/>
           <p:cNvSpPr/>
           <p:nvPr/>
         </p:nvSpPr>
@@ -8288,7 +8398,7 @@
       </p:sp>
       <p:sp>
         <p:nvSpPr>
-          <p:cNvPr id="15403" name="Rounded Rectangle 15402"/>
+          <p:cNvPr id="15404" name="Rounded Rectangle 15403"/>
           <p:cNvSpPr/>
           <p:nvPr/>
         </p:nvSpPr>
@@ -8593,8 +8703,8 @@
         </p:nvSpPr>
         <p:spPr>
           <a:xfrm>
-            <a:off x="-1188720" y="-1188720"/>
-            <a:ext cx="2377440" cy="2377440"/>
+            <a:off x="-868680" y="-868680"/>
+            <a:ext cx="1737360" cy="1737360"/>
           </a:xfrm>
           <a:prstGeom prst="ellipse">
             <a:avLst/>
@@ -8631,7 +8741,62 @@
       </p:sp>
       <p:sp>
         <p:nvSpPr>
-          <p:cNvPr id="17412" name="Rectangle 17411"/>
+          <p:cNvPr id="17412" name="Rounded Rectangle 17411"/>
+          <p:cNvSpPr/>
+          <p:nvPr/>
+        </p:nvSpPr>
+        <p:spPr>
+          <a:xfrm>
+            <a:off x="91440" y="292608"/>
+            <a:ext cx="1207008" cy="329184"/>
+          </a:xfrm>
+          <a:prstGeom prst="roundRect">
+            <a:avLst/>
+          </a:prstGeom>
+          <a:solidFill>
+            <a:srgbClr val="FFFFFF"/>
+          </a:solidFill>
+          <a:ln w="12700">
+            <a:solidFill>
+              <a:srgbClr val="FFFFFF"/>
+            </a:solidFill>
+          </a:ln>
+          <a:effectLst/>
+        </p:spPr>
+        <p:style>
+          <a:lnRef idx="1">
+            <a:schemeClr val="accent1"/>
+          </a:lnRef>
+          <a:fillRef idx="3">
+            <a:schemeClr val="accent1"/>
+          </a:fillRef>
+          <a:effectRef idx="2">
+            <a:schemeClr val="accent1"/>
+          </a:effectRef>
+          <a:fontRef idx="minor">
+            <a:schemeClr val="lt1"/>
+          </a:fontRef>
+        </p:style>
+        <p:txBody>
+          <a:bodyPr rtlCol="0" anchor="ctr" lIns="54864" rIns="54864" tIns="0" bIns="0"/>
+          <a:lstStyle/>
+          <a:p>
+            <a:pPr algn="ctr"/>
+            <a:r>
+              <a:rPr sz="1200" b="1">
+                <a:solidFill>
+                  <a:srgbClr val="422F6C"/>
+                </a:solidFill>
+                <a:latin typeface="Arial"/>
+              </a:rPr>
+              <a:t>Nexus2.O</a:t>
+            </a:r>
+          </a:p>
+        </p:txBody>
+      </p:sp>
+      <p:sp>
+        <p:nvSpPr>
+          <p:cNvPr id="17413" name="Rectangle 17412"/>
           <p:cNvSpPr/>
           <p:nvPr/>
         </p:nvSpPr>
@@ -8684,7 +8849,7 @@
       </p:sp>
       <p:sp>
         <p:nvSpPr>
-          <p:cNvPr id="17413" name="TextBox 17412"/>
+          <p:cNvPr id="17414" name="TextBox 17413"/>
           <p:cNvSpPr txBox="1"/>
           <p:nvPr/>
         </p:nvSpPr>
@@ -8718,7 +8883,7 @@
       </p:sp>
       <p:sp>
         <p:nvSpPr>
-          <p:cNvPr id="17414" name="TextBox 17413"/>
+          <p:cNvPr id="17415" name="TextBox 17414"/>
           <p:cNvSpPr txBox="1"/>
           <p:nvPr/>
         </p:nvSpPr>
@@ -8753,7 +8918,7 @@
       </p:sp>
       <p:sp>
         <p:nvSpPr>
-          <p:cNvPr id="17415" name="Oval 17414"/>
+          <p:cNvPr id="17416" name="Oval 17415"/>
           <p:cNvSpPr/>
           <p:nvPr/>
         </p:nvSpPr>
@@ -8797,7 +8962,7 @@
       </p:sp>
       <p:sp>
         <p:nvSpPr>
-          <p:cNvPr id="17416" name="Rounded Rectangle 17415"/>
+          <p:cNvPr id="17417" name="Rounded Rectangle 17416"/>
           <p:cNvSpPr/>
           <p:nvPr/>
         </p:nvSpPr>
@@ -8876,7 +9041,7 @@
       </p:sp>
       <p:sp>
         <p:nvSpPr>
-          <p:cNvPr id="17417" name="Right Arrow 17416"/>
+          <p:cNvPr id="17418" name="Right Arrow 17417"/>
           <p:cNvSpPr/>
           <p:nvPr/>
         </p:nvSpPr>
@@ -8920,7 +9085,7 @@
       </p:sp>
       <p:sp>
         <p:nvSpPr>
-          <p:cNvPr id="17418" name="Rounded Rectangle 17417"/>
+          <p:cNvPr id="17419" name="Rounded Rectangle 17418"/>
           <p:cNvSpPr/>
           <p:nvPr/>
         </p:nvSpPr>
@@ -8987,7 +9152,7 @@
       </p:sp>
       <p:sp>
         <p:nvSpPr>
-          <p:cNvPr id="17419" name="Right Arrow 17418"/>
+          <p:cNvPr id="17420" name="Right Arrow 17419"/>
           <p:cNvSpPr/>
           <p:nvPr/>
         </p:nvSpPr>
@@ -9031,7 +9196,7 @@
       </p:sp>
       <p:sp>
         <p:nvSpPr>
-          <p:cNvPr id="17420" name="Rounded Rectangle 17419"/>
+          <p:cNvPr id="17421" name="Rounded Rectangle 17420"/>
           <p:cNvSpPr/>
           <p:nvPr/>
         </p:nvSpPr>
@@ -9098,7 +9263,7 @@
       </p:sp>
       <p:sp>
         <p:nvSpPr>
-          <p:cNvPr id="17421" name="Right Arrow 17420"/>
+          <p:cNvPr id="17422" name="Right Arrow 17421"/>
           <p:cNvSpPr/>
           <p:nvPr/>
         </p:nvSpPr>
@@ -9142,7 +9307,7 @@
       </p:sp>
       <p:sp>
         <p:nvSpPr>
-          <p:cNvPr id="17422" name="Rounded Rectangle 17421"/>
+          <p:cNvPr id="17423" name="Rounded Rectangle 17422"/>
           <p:cNvSpPr/>
           <p:nvPr/>
         </p:nvSpPr>
@@ -9221,7 +9386,7 @@
       </p:sp>
       <p:sp>
         <p:nvSpPr>
-          <p:cNvPr id="17423" name="Right Arrow 17422"/>
+          <p:cNvPr id="17424" name="Right Arrow 17423"/>
           <p:cNvSpPr/>
           <p:nvPr/>
         </p:nvSpPr>
@@ -9265,7 +9430,7 @@
       </p:sp>
       <p:sp>
         <p:nvSpPr>
-          <p:cNvPr id="17424" name="Rounded Rectangle 17423"/>
+          <p:cNvPr id="17425" name="Rounded Rectangle 17424"/>
           <p:cNvSpPr/>
           <p:nvPr/>
         </p:nvSpPr>
@@ -9344,7 +9509,7 @@
       </p:sp>
       <p:sp>
         <p:nvSpPr>
-          <p:cNvPr id="17425" name="Right Arrow 17424"/>
+          <p:cNvPr id="17426" name="Right Arrow 17425"/>
           <p:cNvSpPr/>
           <p:nvPr/>
         </p:nvSpPr>
@@ -9388,7 +9553,7 @@
       </p:sp>
       <p:sp>
         <p:nvSpPr>
-          <p:cNvPr id="17426" name="Rounded Rectangle 17425"/>
+          <p:cNvPr id="17427" name="Rounded Rectangle 17426"/>
           <p:cNvSpPr/>
           <p:nvPr/>
         </p:nvSpPr>
@@ -9467,7 +9632,7 @@
       </p:sp>
       <p:sp>
         <p:nvSpPr>
-          <p:cNvPr id="17427" name="Right Arrow 17426"/>
+          <p:cNvPr id="17428" name="Right Arrow 17427"/>
           <p:cNvSpPr/>
           <p:nvPr/>
         </p:nvSpPr>
@@ -9511,7 +9676,7 @@
       </p:sp>
       <p:sp>
         <p:nvSpPr>
-          <p:cNvPr id="17428" name="Rounded Rectangle 17427"/>
+          <p:cNvPr id="17429" name="Rounded Rectangle 17428"/>
           <p:cNvSpPr/>
           <p:nvPr/>
         </p:nvSpPr>
@@ -9590,7 +9755,7 @@
       </p:sp>
       <p:sp>
         <p:nvSpPr>
-          <p:cNvPr id="17429" name="Right Arrow 17428"/>
+          <p:cNvPr id="17430" name="Right Arrow 17429"/>
           <p:cNvSpPr/>
           <p:nvPr/>
         </p:nvSpPr>
@@ -9634,7 +9799,7 @@
       </p:sp>
       <p:sp>
         <p:nvSpPr>
-          <p:cNvPr id="17430" name="Rounded Rectangle 17429"/>
+          <p:cNvPr id="17431" name="Rounded Rectangle 17430"/>
           <p:cNvSpPr/>
           <p:nvPr/>
         </p:nvSpPr>
@@ -9713,7 +9878,7 @@
       </p:sp>
       <p:sp>
         <p:nvSpPr>
-          <p:cNvPr id="17431" name="Rounded Rectangle 17430"/>
+          <p:cNvPr id="17432" name="Rounded Rectangle 17431"/>
           <p:cNvSpPr/>
           <p:nvPr/>
         </p:nvSpPr>
@@ -9792,7 +9957,7 @@
       </p:sp>
       <p:sp>
         <p:nvSpPr>
-          <p:cNvPr id="17432" name="Rounded Rectangle 17431"/>
+          <p:cNvPr id="17433" name="Rounded Rectangle 17432"/>
           <p:cNvSpPr/>
           <p:nvPr/>
         </p:nvSpPr>
@@ -9871,7 +10036,7 @@
       </p:sp>
       <p:sp>
         <p:nvSpPr>
-          <p:cNvPr id="17433" name="Rounded Rectangle 17432"/>
+          <p:cNvPr id="17434" name="Rounded Rectangle 17433"/>
           <p:cNvSpPr/>
           <p:nvPr/>
         </p:nvSpPr>
@@ -9950,7 +10115,7 @@
       </p:sp>
       <p:sp>
         <p:nvSpPr>
-          <p:cNvPr id="17434" name="Rounded Rectangle 17433"/>
+          <p:cNvPr id="17435" name="Rounded Rectangle 17434"/>
           <p:cNvSpPr/>
           <p:nvPr/>
         </p:nvSpPr>
@@ -10029,7 +10194,7 @@
       </p:sp>
       <p:sp>
         <p:nvSpPr>
-          <p:cNvPr id="17435" name="Down Arrow 17434"/>
+          <p:cNvPr id="17436" name="Down Arrow 17435"/>
           <p:cNvSpPr/>
           <p:nvPr/>
         </p:nvSpPr>
@@ -10073,7 +10238,7 @@
       </p:sp>
       <p:sp>
         <p:nvSpPr>
-          <p:cNvPr id="17436" name="TextBox 17435"/>
+          <p:cNvPr id="17437" name="TextBox 17436"/>
           <p:cNvSpPr txBox="1"/>
           <p:nvPr/>
         </p:nvSpPr>
@@ -10107,7 +10272,7 @@
       </p:sp>
       <p:sp>
         <p:nvSpPr>
-          <p:cNvPr id="17437" name="Rounded Rectangle 17436"/>
+          <p:cNvPr id="17438" name="Rounded Rectangle 17437"/>
           <p:cNvSpPr/>
           <p:nvPr/>
         </p:nvSpPr>
@@ -10175,7 +10340,7 @@
       </p:sp>
       <p:sp>
         <p:nvSpPr>
-          <p:cNvPr id="17438" name="Rounded Rectangle 17437"/>
+          <p:cNvPr id="17439" name="Rounded Rectangle 17438"/>
           <p:cNvSpPr/>
           <p:nvPr/>
         </p:nvSpPr>
@@ -10243,7 +10408,7 @@
       </p:sp>
       <p:sp>
         <p:nvSpPr>
-          <p:cNvPr id="17439" name="Rounded Rectangle 17438"/>
+          <p:cNvPr id="17440" name="Rounded Rectangle 17439"/>
           <p:cNvSpPr/>
           <p:nvPr/>
         </p:nvSpPr>
@@ -10311,7 +10476,7 @@
       </p:sp>
       <p:sp>
         <p:nvSpPr>
-          <p:cNvPr id="17440" name="Rounded Rectangle 17439"/>
+          <p:cNvPr id="17441" name="Rounded Rectangle 17440"/>
           <p:cNvSpPr/>
           <p:nvPr/>
         </p:nvSpPr>
@@ -10379,7 +10544,7 @@
       </p:sp>
       <p:sp>
         <p:nvSpPr>
-          <p:cNvPr id="17441" name="TextBox 17440"/>
+          <p:cNvPr id="17442" name="TextBox 17441"/>
           <p:cNvSpPr txBox="1"/>
           <p:nvPr/>
         </p:nvSpPr>
@@ -10413,7 +10578,7 @@
       </p:sp>
       <p:sp>
         <p:nvSpPr>
-          <p:cNvPr id="17442" name="Rounded Rectangle 17441"/>
+          <p:cNvPr id="17443" name="Rounded Rectangle 17442"/>
           <p:cNvSpPr/>
           <p:nvPr/>
         </p:nvSpPr>
@@ -10843,8 +11008,8 @@
         </p:nvSpPr>
         <p:spPr>
           <a:xfrm>
-            <a:off x="-1188720" y="-1188720"/>
-            <a:ext cx="2377440" cy="2377440"/>
+            <a:off x="-868680" y="-868680"/>
+            <a:ext cx="1737360" cy="1737360"/>
           </a:xfrm>
           <a:prstGeom prst="ellipse">
             <a:avLst/>
@@ -10881,7 +11046,62 @@
       </p:sp>
       <p:sp>
         <p:nvSpPr>
-          <p:cNvPr id="17412" name="Rectangle 17411"/>
+          <p:cNvPr id="17412" name="Rounded Rectangle 17411"/>
+          <p:cNvSpPr/>
+          <p:nvPr/>
+        </p:nvSpPr>
+        <p:spPr>
+          <a:xfrm>
+            <a:off x="91440" y="292608"/>
+            <a:ext cx="1207008" cy="329184"/>
+          </a:xfrm>
+          <a:prstGeom prst="roundRect">
+            <a:avLst/>
+          </a:prstGeom>
+          <a:solidFill>
+            <a:srgbClr val="FFFFFF"/>
+          </a:solidFill>
+          <a:ln w="12700">
+            <a:solidFill>
+              <a:srgbClr val="FFFFFF"/>
+            </a:solidFill>
+          </a:ln>
+          <a:effectLst/>
+        </p:spPr>
+        <p:style>
+          <a:lnRef idx="1">
+            <a:schemeClr val="accent1"/>
+          </a:lnRef>
+          <a:fillRef idx="3">
+            <a:schemeClr val="accent1"/>
+          </a:fillRef>
+          <a:effectRef idx="2">
+            <a:schemeClr val="accent1"/>
+          </a:effectRef>
+          <a:fontRef idx="minor">
+            <a:schemeClr val="lt1"/>
+          </a:fontRef>
+        </p:style>
+        <p:txBody>
+          <a:bodyPr rtlCol="0" anchor="ctr" lIns="54864" rIns="54864" tIns="0" bIns="0"/>
+          <a:lstStyle/>
+          <a:p>
+            <a:pPr algn="ctr"/>
+            <a:r>
+              <a:rPr sz="1200" b="1">
+                <a:solidFill>
+                  <a:srgbClr val="422F6C"/>
+                </a:solidFill>
+                <a:latin typeface="Arial"/>
+              </a:rPr>
+              <a:t>Nexus2.O</a:t>
+            </a:r>
+          </a:p>
+        </p:txBody>
+      </p:sp>
+      <p:sp>
+        <p:nvSpPr>
+          <p:cNvPr id="17413" name="Rectangle 17412"/>
           <p:cNvSpPr/>
           <p:nvPr/>
         </p:nvSpPr>
@@ -10934,7 +11154,7 @@
       </p:sp>
       <p:sp>
         <p:nvSpPr>
-          <p:cNvPr id="17413" name="TextBox 17412"/>
+          <p:cNvPr id="17414" name="TextBox 17413"/>
           <p:cNvSpPr txBox="1"/>
           <p:nvPr/>
         </p:nvSpPr>
@@ -10968,7 +11188,7 @@
       </p:sp>
       <p:sp>
         <p:nvSpPr>
-          <p:cNvPr id="17414" name="TextBox 17413"/>
+          <p:cNvPr id="17415" name="TextBox 17414"/>
           <p:cNvSpPr txBox="1"/>
           <p:nvPr/>
         </p:nvSpPr>
@@ -11003,7 +11223,7 @@
       </p:sp>
       <p:sp>
         <p:nvSpPr>
-          <p:cNvPr id="17415" name="Oval 17414"/>
+          <p:cNvPr id="17416" name="Oval 17415"/>
           <p:cNvSpPr/>
           <p:nvPr/>
         </p:nvSpPr>
@@ -11047,7 +11267,7 @@
       </p:sp>
       <p:sp>
         <p:nvSpPr>
-          <p:cNvPr id="17416" name="Rounded Rectangle 17415"/>
+          <p:cNvPr id="17417" name="Rounded Rectangle 17416"/>
           <p:cNvSpPr/>
           <p:nvPr/>
         </p:nvSpPr>
@@ -11100,7 +11320,7 @@
       </p:sp>
       <p:sp>
         <p:nvSpPr>
-          <p:cNvPr id="17417" name="Rounded Rectangle 17416"/>
+          <p:cNvPr id="17418" name="Rounded Rectangle 17417"/>
           <p:cNvSpPr/>
           <p:nvPr/>
         </p:nvSpPr>
@@ -11153,7 +11373,7 @@
       </p:sp>
       <p:sp>
         <p:nvSpPr>
-          <p:cNvPr id="17418" name="TextBox 17417"/>
+          <p:cNvPr id="17419" name="TextBox 17418"/>
           <p:cNvSpPr txBox="1"/>
           <p:nvPr/>
         </p:nvSpPr>
@@ -11197,7 +11417,7 @@
       </p:sp>
       <p:sp>
         <p:nvSpPr>
-          <p:cNvPr id="17419" name="Right Arrow 17418"/>
+          <p:cNvPr id="17420" name="Right Arrow 17419"/>
           <p:cNvSpPr/>
           <p:nvPr/>
         </p:nvSpPr>
@@ -11241,7 +11461,7 @@
       </p:sp>
       <p:sp>
         <p:nvSpPr>
-          <p:cNvPr id="17420" name="TextBox 17419"/>
+          <p:cNvPr id="17421" name="TextBox 17420"/>
           <p:cNvSpPr txBox="1"/>
           <p:nvPr/>
         </p:nvSpPr>
@@ -11275,7 +11495,7 @@
       </p:sp>
       <p:cxnSp>
         <p:nvCxnSpPr>
-          <p:cNvPr id="17421" name="Connector 17420"/>
+          <p:cNvPr id="17422" name="Connector 17421"/>
           <p:cNvCxnSpPr/>
           <p:nvPr/>
         </p:nvCxnSpPr>
@@ -11310,7 +11530,7 @@
       </p:cxnSp>
       <p:sp>
         <p:nvSpPr>
-          <p:cNvPr id="17422" name="TextBox 17421"/>
+          <p:cNvPr id="17423" name="TextBox 17422"/>
           <p:cNvSpPr txBox="1"/>
           <p:nvPr/>
         </p:nvSpPr>
@@ -11354,7 +11574,7 @@
       </p:sp>
       <p:sp>
         <p:nvSpPr>
-          <p:cNvPr id="17423" name="Right Arrow 17422"/>
+          <p:cNvPr id="17424" name="Right Arrow 17423"/>
           <p:cNvSpPr/>
           <p:nvPr/>
         </p:nvSpPr>
@@ -11398,7 +11618,7 @@
       </p:sp>
       <p:sp>
         <p:nvSpPr>
-          <p:cNvPr id="17424" name="TextBox 17423"/>
+          <p:cNvPr id="17425" name="TextBox 17424"/>
           <p:cNvSpPr txBox="1"/>
           <p:nvPr/>
         </p:nvSpPr>
@@ -11432,7 +11652,7 @@
       </p:sp>
       <p:cxnSp>
         <p:nvCxnSpPr>
-          <p:cNvPr id="17425" name="Connector 17424"/>
+          <p:cNvPr id="17426" name="Connector 17425"/>
           <p:cNvCxnSpPr/>
           <p:nvPr/>
         </p:nvCxnSpPr>
@@ -11467,7 +11687,7 @@
       </p:cxnSp>
       <p:sp>
         <p:nvSpPr>
-          <p:cNvPr id="17426" name="TextBox 17425"/>
+          <p:cNvPr id="17427" name="TextBox 17426"/>
           <p:cNvSpPr txBox="1"/>
           <p:nvPr/>
         </p:nvSpPr>
@@ -11510,7 +11730,7 @@
       </p:sp>
       <p:sp>
         <p:nvSpPr>
-          <p:cNvPr id="17427" name="Right Arrow 17426"/>
+          <p:cNvPr id="17428" name="Right Arrow 17427"/>
           <p:cNvSpPr/>
           <p:nvPr/>
         </p:nvSpPr>
@@ -11554,7 +11774,7 @@
       </p:sp>
       <p:sp>
         <p:nvSpPr>
-          <p:cNvPr id="17428" name="TextBox 17427"/>
+          <p:cNvPr id="17429" name="TextBox 17428"/>
           <p:cNvSpPr txBox="1"/>
           <p:nvPr/>
         </p:nvSpPr>
@@ -11588,7 +11808,7 @@
       </p:sp>
       <p:cxnSp>
         <p:nvCxnSpPr>
-          <p:cNvPr id="17429" name="Connector 17428"/>
+          <p:cNvPr id="17430" name="Connector 17429"/>
           <p:cNvCxnSpPr/>
           <p:nvPr/>
         </p:nvCxnSpPr>
@@ -11623,7 +11843,7 @@
       </p:cxnSp>
       <p:sp>
         <p:nvSpPr>
-          <p:cNvPr id="17430" name="TextBox 17429"/>
+          <p:cNvPr id="17431" name="TextBox 17430"/>
           <p:cNvSpPr txBox="1"/>
           <p:nvPr/>
         </p:nvSpPr>
@@ -11667,7 +11887,7 @@
       </p:sp>
       <p:sp>
         <p:nvSpPr>
-          <p:cNvPr id="17431" name="Right Arrow 17430"/>
+          <p:cNvPr id="17432" name="Right Arrow 17431"/>
           <p:cNvSpPr/>
           <p:nvPr/>
         </p:nvSpPr>
@@ -11711,7 +11931,7 @@
       </p:sp>
       <p:sp>
         <p:nvSpPr>
-          <p:cNvPr id="17432" name="TextBox 17431"/>
+          <p:cNvPr id="17433" name="TextBox 17432"/>
           <p:cNvSpPr txBox="1"/>
           <p:nvPr/>
         </p:nvSpPr>
@@ -11745,7 +11965,7 @@
       </p:sp>
       <p:cxnSp>
         <p:nvCxnSpPr>
-          <p:cNvPr id="17433" name="Connector 17432"/>
+          <p:cNvPr id="17434" name="Connector 17433"/>
           <p:cNvCxnSpPr/>
           <p:nvPr/>
         </p:nvCxnSpPr>
@@ -11780,7 +12000,7 @@
       </p:cxnSp>
       <p:sp>
         <p:nvSpPr>
-          <p:cNvPr id="17434" name="TextBox 17433"/>
+          <p:cNvPr id="17435" name="TextBox 17434"/>
           <p:cNvSpPr txBox="1"/>
           <p:nvPr/>
         </p:nvSpPr>
@@ -11823,7 +12043,7 @@
       </p:sp>
       <p:sp>
         <p:nvSpPr>
-          <p:cNvPr id="17435" name="Right Arrow 17434"/>
+          <p:cNvPr id="17436" name="Right Arrow 17435"/>
           <p:cNvSpPr/>
           <p:nvPr/>
         </p:nvSpPr>
@@ -11867,7 +12087,7 @@
       </p:sp>
       <p:sp>
         <p:nvSpPr>
-          <p:cNvPr id="17436" name="TextBox 17435"/>
+          <p:cNvPr id="17437" name="TextBox 17436"/>
           <p:cNvSpPr txBox="1"/>
           <p:nvPr/>
         </p:nvSpPr>
@@ -11901,7 +12121,7 @@
       </p:sp>
       <p:cxnSp>
         <p:nvCxnSpPr>
-          <p:cNvPr id="17437" name="Connector 17436"/>
+          <p:cNvPr id="17438" name="Connector 17437"/>
           <p:cNvCxnSpPr/>
           <p:nvPr/>
         </p:nvCxnSpPr>
@@ -11936,7 +12156,7 @@
       </p:cxnSp>
       <p:sp>
         <p:nvSpPr>
-          <p:cNvPr id="17438" name="Rounded Rectangle 17437"/>
+          <p:cNvPr id="17439" name="Rounded Rectangle 17438"/>
           <p:cNvSpPr/>
           <p:nvPr/>
         </p:nvSpPr>
@@ -11989,7 +12209,7 @@
       </p:sp>
       <p:sp>
         <p:nvSpPr>
-          <p:cNvPr id="17439" name="Rounded Rectangle 17438"/>
+          <p:cNvPr id="17440" name="Rounded Rectangle 17439"/>
           <p:cNvSpPr/>
           <p:nvPr/>
         </p:nvSpPr>
@@ -12033,7 +12253,7 @@
       </p:sp>
       <p:pic>
         <p:nvPicPr>
-          <p:cNvPr id="17440" name="Picture 17439" descr="actor_profile_new.jpg"/>
+          <p:cNvPr id="17441" name="Picture 17440" descr="actor_profile_new.jpg"/>
           <p:cNvPicPr>
             <a:picLocks noChangeAspect="1"/>
           </p:cNvPicPr>
@@ -12057,7 +12277,7 @@
       </p:pic>
       <p:sp>
         <p:nvSpPr>
-          <p:cNvPr id="17441" name="Rounded Rectangle 17440"/>
+          <p:cNvPr id="17442" name="Rounded Rectangle 17441"/>
           <p:cNvSpPr/>
           <p:nvPr/>
         </p:nvSpPr>
@@ -12167,7 +12387,7 @@
       </p:sp>
       <p:sp>
         <p:nvSpPr>
-          <p:cNvPr id="17442" name="Rounded Rectangle 17441"/>
+          <p:cNvPr id="17443" name="Rounded Rectangle 17442"/>
           <p:cNvSpPr/>
           <p:nvPr/>
         </p:nvSpPr>
@@ -12600,8 +12820,8 @@
         </p:nvSpPr>
         <p:spPr>
           <a:xfrm>
-            <a:off x="-1188720" y="-1188720"/>
-            <a:ext cx="2377440" cy="2377440"/>
+            <a:off x="-868680" y="-868680"/>
+            <a:ext cx="1737360" cy="1737360"/>
           </a:xfrm>
           <a:prstGeom prst="ellipse">
             <a:avLst/>
@@ -12638,7 +12858,62 @@
       </p:sp>
       <p:sp>
         <p:nvSpPr>
-          <p:cNvPr id="17412" name="Rectangle 17411"/>
+          <p:cNvPr id="17412" name="Rounded Rectangle 17411"/>
+          <p:cNvSpPr/>
+          <p:nvPr/>
+        </p:nvSpPr>
+        <p:spPr>
+          <a:xfrm>
+            <a:off x="91440" y="292608"/>
+            <a:ext cx="1207008" cy="329184"/>
+          </a:xfrm>
+          <a:prstGeom prst="roundRect">
+            <a:avLst/>
+          </a:prstGeom>
+          <a:solidFill>
+            <a:srgbClr val="FFFFFF"/>
+          </a:solidFill>
+          <a:ln w="12700">
+            <a:solidFill>
+              <a:srgbClr val="FFFFFF"/>
+            </a:solidFill>
+          </a:ln>
+          <a:effectLst/>
+        </p:spPr>
+        <p:style>
+          <a:lnRef idx="1">
+            <a:schemeClr val="accent1"/>
+          </a:lnRef>
+          <a:fillRef idx="3">
+            <a:schemeClr val="accent1"/>
+          </a:fillRef>
+          <a:effectRef idx="2">
+            <a:schemeClr val="accent1"/>
+          </a:effectRef>
+          <a:fontRef idx="minor">
+            <a:schemeClr val="lt1"/>
+          </a:fontRef>
+        </p:style>
+        <p:txBody>
+          <a:bodyPr rtlCol="0" anchor="ctr" lIns="54864" rIns="54864" tIns="0" bIns="0"/>
+          <a:lstStyle/>
+          <a:p>
+            <a:pPr algn="ctr"/>
+            <a:r>
+              <a:rPr sz="1200" b="1">
+                <a:solidFill>
+                  <a:srgbClr val="422F6C"/>
+                </a:solidFill>
+                <a:latin typeface="Arial"/>
+              </a:rPr>
+              <a:t>Nexus2.O</a:t>
+            </a:r>
+          </a:p>
+        </p:txBody>
+      </p:sp>
+      <p:sp>
+        <p:nvSpPr>
+          <p:cNvPr id="17413" name="Rectangle 17412"/>
           <p:cNvSpPr/>
           <p:nvPr/>
         </p:nvSpPr>
@@ -12691,7 +12966,7 @@
       </p:sp>
       <p:sp>
         <p:nvSpPr>
-          <p:cNvPr id="17413" name="TextBox 17412"/>
+          <p:cNvPr id="17414" name="TextBox 17413"/>
           <p:cNvSpPr txBox="1"/>
           <p:nvPr/>
         </p:nvSpPr>
@@ -12725,7 +13000,7 @@
       </p:sp>
       <p:sp>
         <p:nvSpPr>
-          <p:cNvPr id="17414" name="TextBox 17413"/>
+          <p:cNvPr id="17415" name="TextBox 17414"/>
           <p:cNvSpPr txBox="1"/>
           <p:nvPr/>
         </p:nvSpPr>
@@ -12760,7 +13035,7 @@
       </p:sp>
       <p:sp>
         <p:nvSpPr>
-          <p:cNvPr id="17415" name="Oval 17414"/>
+          <p:cNvPr id="17416" name="Oval 17415"/>
           <p:cNvSpPr/>
           <p:nvPr/>
         </p:nvSpPr>
@@ -12804,7 +13079,7 @@
       </p:sp>
       <p:sp>
         <p:nvSpPr>
-          <p:cNvPr id="17416" name="Rounded Rectangle 17415"/>
+          <p:cNvPr id="17417" name="Rounded Rectangle 17416"/>
           <p:cNvSpPr/>
           <p:nvPr/>
         </p:nvSpPr>
@@ -12881,7 +13156,7 @@
       </p:sp>
       <p:sp>
         <p:nvSpPr>
-          <p:cNvPr id="17417" name="Right Arrow 17416"/>
+          <p:cNvPr id="17418" name="Right Arrow 17417"/>
           <p:cNvSpPr/>
           <p:nvPr/>
         </p:nvSpPr>
@@ -12925,7 +13200,7 @@
       </p:sp>
       <p:sp>
         <p:nvSpPr>
-          <p:cNvPr id="17418" name="Rounded Rectangle 17417"/>
+          <p:cNvPr id="17419" name="Rounded Rectangle 17418"/>
           <p:cNvSpPr/>
           <p:nvPr/>
         </p:nvSpPr>
@@ -12978,7 +13253,7 @@
       </p:sp>
       <p:sp>
         <p:nvSpPr>
-          <p:cNvPr id="17419" name="Right Arrow 17418"/>
+          <p:cNvPr id="17420" name="Right Arrow 17419"/>
           <p:cNvSpPr/>
           <p:nvPr/>
         </p:nvSpPr>
@@ -13022,7 +13297,7 @@
       </p:sp>
       <p:sp>
         <p:nvSpPr>
-          <p:cNvPr id="17420" name="Rounded Rectangle 17419"/>
+          <p:cNvPr id="17421" name="Rounded Rectangle 17420"/>
           <p:cNvSpPr/>
           <p:nvPr/>
         </p:nvSpPr>
@@ -13087,7 +13362,7 @@
       </p:sp>
       <p:sp>
         <p:nvSpPr>
-          <p:cNvPr id="17421" name="Right Arrow 17420"/>
+          <p:cNvPr id="17422" name="Right Arrow 17421"/>
           <p:cNvSpPr/>
           <p:nvPr/>
         </p:nvSpPr>
@@ -13131,7 +13406,7 @@
       </p:sp>
       <p:sp>
         <p:nvSpPr>
-          <p:cNvPr id="17422" name="Rounded Rectangle 17421"/>
+          <p:cNvPr id="17423" name="Rounded Rectangle 17422"/>
           <p:cNvSpPr/>
           <p:nvPr/>
         </p:nvSpPr>
@@ -13196,7 +13471,7 @@
       </p:sp>
       <p:sp>
         <p:nvSpPr>
-          <p:cNvPr id="17423" name="Right Arrow 17422"/>
+          <p:cNvPr id="17424" name="Right Arrow 17423"/>
           <p:cNvSpPr/>
           <p:nvPr/>
         </p:nvSpPr>
@@ -13240,7 +13515,7 @@
       </p:sp>
       <p:sp>
         <p:nvSpPr>
-          <p:cNvPr id="17424" name="Rounded Rectangle 17423"/>
+          <p:cNvPr id="17425" name="Rounded Rectangle 17424"/>
           <p:cNvSpPr/>
           <p:nvPr/>
         </p:nvSpPr>
@@ -13305,7 +13580,7 @@
       </p:sp>
       <p:sp>
         <p:nvSpPr>
-          <p:cNvPr id="17425" name="Rounded Rectangle 17424"/>
+          <p:cNvPr id="17426" name="Rounded Rectangle 17425"/>
           <p:cNvSpPr/>
           <p:nvPr/>
         </p:nvSpPr>
@@ -13405,7 +13680,7 @@
       </p:sp>
       <p:sp>
         <p:nvSpPr>
-          <p:cNvPr id="17426" name="Rounded Rectangle 17425"/>
+          <p:cNvPr id="17427" name="Rounded Rectangle 17426"/>
           <p:cNvSpPr/>
           <p:nvPr/>
         </p:nvSpPr>
@@ -13505,7 +13780,7 @@
       </p:sp>
       <p:sp>
         <p:nvSpPr>
-          <p:cNvPr id="17427" name="Rounded Rectangle 17426"/>
+          <p:cNvPr id="17428" name="Rounded Rectangle 17427"/>
           <p:cNvSpPr/>
           <p:nvPr/>
         </p:nvSpPr>
@@ -13605,7 +13880,7 @@
       </p:sp>
       <p:sp>
         <p:nvSpPr>
-          <p:cNvPr id="17428" name="Rounded Rectangle 17427"/>
+          <p:cNvPr id="17429" name="Rounded Rectangle 17428"/>
           <p:cNvSpPr/>
           <p:nvPr/>
         </p:nvSpPr>
@@ -13705,7 +13980,7 @@
       </p:sp>
       <p:sp>
         <p:nvSpPr>
-          <p:cNvPr id="17429" name="TextBox 17428"/>
+          <p:cNvPr id="17430" name="TextBox 17429"/>
           <p:cNvSpPr txBox="1"/>
           <p:nvPr/>
         </p:nvSpPr>
@@ -13739,7 +14014,7 @@
       </p:sp>
       <p:sp>
         <p:nvSpPr>
-          <p:cNvPr id="17430" name="Rounded Rectangle 17429"/>
+          <p:cNvPr id="17431" name="Rounded Rectangle 17430"/>
           <p:cNvSpPr/>
           <p:nvPr/>
         </p:nvSpPr>
@@ -13807,7 +14082,7 @@
       </p:sp>
       <p:sp>
         <p:nvSpPr>
-          <p:cNvPr id="17431" name="Rounded Rectangle 17430"/>
+          <p:cNvPr id="17432" name="Rounded Rectangle 17431"/>
           <p:cNvSpPr/>
           <p:nvPr/>
         </p:nvSpPr>
@@ -13875,7 +14150,7 @@
       </p:sp>
       <p:sp>
         <p:nvSpPr>
-          <p:cNvPr id="17432" name="Rounded Rectangle 17431"/>
+          <p:cNvPr id="17433" name="Rounded Rectangle 17432"/>
           <p:cNvSpPr/>
           <p:nvPr/>
         </p:nvSpPr>
@@ -13943,7 +14218,7 @@
       </p:sp>
       <p:sp>
         <p:nvSpPr>
-          <p:cNvPr id="17433" name="Rounded Rectangle 17432"/>
+          <p:cNvPr id="17434" name="Rounded Rectangle 17433"/>
           <p:cNvSpPr/>
           <p:nvPr/>
         </p:nvSpPr>
@@ -14393,8 +14668,8 @@
         </p:nvSpPr>
         <p:spPr>
           <a:xfrm>
-            <a:off x="-1188720" y="-1188720"/>
-            <a:ext cx="2377440" cy="2377440"/>
+            <a:off x="-868680" y="-868680"/>
+            <a:ext cx="1737360" cy="1737360"/>
           </a:xfrm>
           <a:prstGeom prst="ellipse">
             <a:avLst/>
@@ -14431,7 +14706,62 @@
       </p:sp>
       <p:sp>
         <p:nvSpPr>
-          <p:cNvPr id="17412" name="Rectangle 17411"/>
+          <p:cNvPr id="17412" name="Rounded Rectangle 17411"/>
+          <p:cNvSpPr/>
+          <p:nvPr/>
+        </p:nvSpPr>
+        <p:spPr>
+          <a:xfrm>
+            <a:off x="91440" y="292608"/>
+            <a:ext cx="1207008" cy="329184"/>
+          </a:xfrm>
+          <a:prstGeom prst="roundRect">
+            <a:avLst/>
+          </a:prstGeom>
+          <a:solidFill>
+            <a:srgbClr val="FFFFFF"/>
+          </a:solidFill>
+          <a:ln w="12700">
+            <a:solidFill>
+              <a:srgbClr val="FFFFFF"/>
+            </a:solidFill>
+          </a:ln>
+          <a:effectLst/>
+        </p:spPr>
+        <p:style>
+          <a:lnRef idx="1">
+            <a:schemeClr val="accent1"/>
+          </a:lnRef>
+          <a:fillRef idx="3">
+            <a:schemeClr val="accent1"/>
+          </a:fillRef>
+          <a:effectRef idx="2">
+            <a:schemeClr val="accent1"/>
+          </a:effectRef>
+          <a:fontRef idx="minor">
+            <a:schemeClr val="lt1"/>
+          </a:fontRef>
+        </p:style>
+        <p:txBody>
+          <a:bodyPr rtlCol="0" anchor="ctr" lIns="54864" rIns="54864" tIns="0" bIns="0"/>
+          <a:lstStyle/>
+          <a:p>
+            <a:pPr algn="ctr"/>
+            <a:r>
+              <a:rPr sz="1200" b="1">
+                <a:solidFill>
+                  <a:srgbClr val="422F6C"/>
+                </a:solidFill>
+                <a:latin typeface="Arial"/>
+              </a:rPr>
+              <a:t>Nexus2.O</a:t>
+            </a:r>
+          </a:p>
+        </p:txBody>
+      </p:sp>
+      <p:sp>
+        <p:nvSpPr>
+          <p:cNvPr id="17413" name="Rectangle 17412"/>
           <p:cNvSpPr/>
           <p:nvPr/>
         </p:nvSpPr>
@@ -14484,7 +14814,7 @@
       </p:sp>
       <p:sp>
         <p:nvSpPr>
-          <p:cNvPr id="17413" name="TextBox 17412"/>
+          <p:cNvPr id="17414" name="TextBox 17413"/>
           <p:cNvSpPr txBox="1"/>
           <p:nvPr/>
         </p:nvSpPr>
@@ -14518,7 +14848,7 @@
       </p:sp>
       <p:sp>
         <p:nvSpPr>
-          <p:cNvPr id="17414" name="TextBox 17413"/>
+          <p:cNvPr id="17415" name="TextBox 17414"/>
           <p:cNvSpPr txBox="1"/>
           <p:nvPr/>
         </p:nvSpPr>
@@ -14553,7 +14883,7 @@
       </p:sp>
       <p:sp>
         <p:nvSpPr>
-          <p:cNvPr id="17415" name="Oval 17414"/>
+          <p:cNvPr id="17416" name="Oval 17415"/>
           <p:cNvSpPr/>
           <p:nvPr/>
         </p:nvSpPr>
@@ -14597,7 +14927,7 @@
       </p:sp>
       <p:sp>
         <p:nvSpPr>
-          <p:cNvPr id="17416" name="Rounded Rectangle 17415"/>
+          <p:cNvPr id="17417" name="Rounded Rectangle 17416"/>
           <p:cNvSpPr/>
           <p:nvPr/>
         </p:nvSpPr>
@@ -14661,7 +14991,7 @@
       </p:sp>
       <p:sp>
         <p:nvSpPr>
-          <p:cNvPr id="17417" name="Rounded Rectangle 17416"/>
+          <p:cNvPr id="17418" name="Rounded Rectangle 17417"/>
           <p:cNvSpPr/>
           <p:nvPr/>
         </p:nvSpPr>
@@ -14725,7 +15055,7 @@
       </p:sp>
       <p:sp>
         <p:nvSpPr>
-          <p:cNvPr id="17418" name="Rounded Rectangle 17417"/>
+          <p:cNvPr id="17419" name="Rounded Rectangle 17418"/>
           <p:cNvSpPr/>
           <p:nvPr/>
         </p:nvSpPr>
@@ -14789,7 +15119,7 @@
       </p:sp>
       <p:sp>
         <p:nvSpPr>
-          <p:cNvPr id="17419" name="Rounded Rectangle 17418"/>
+          <p:cNvPr id="17420" name="Rounded Rectangle 17419"/>
           <p:cNvSpPr/>
           <p:nvPr/>
         </p:nvSpPr>
@@ -14853,7 +15183,7 @@
       </p:sp>
       <p:sp>
         <p:nvSpPr>
-          <p:cNvPr id="17420" name="Rounded Rectangle 17419"/>
+          <p:cNvPr id="17421" name="Rounded Rectangle 17420"/>
           <p:cNvSpPr/>
           <p:nvPr/>
         </p:nvSpPr>
@@ -14917,7 +15247,7 @@
       </p:sp>
       <p:sp>
         <p:nvSpPr>
-          <p:cNvPr id="17421" name="Rounded Rectangle 17420"/>
+          <p:cNvPr id="17422" name="Rounded Rectangle 17421"/>
           <p:cNvSpPr/>
           <p:nvPr/>
         </p:nvSpPr>
@@ -14981,7 +15311,7 @@
       </p:sp>
       <p:sp>
         <p:nvSpPr>
-          <p:cNvPr id="17422" name="Rounded Rectangle 17421"/>
+          <p:cNvPr id="17423" name="Rounded Rectangle 17422"/>
           <p:cNvSpPr/>
           <p:nvPr/>
         </p:nvSpPr>
@@ -15045,7 +15375,7 @@
       </p:sp>
       <p:sp>
         <p:nvSpPr>
-          <p:cNvPr id="17423" name="Rounded Rectangle 17422"/>
+          <p:cNvPr id="17424" name="Rounded Rectangle 17423"/>
           <p:cNvSpPr/>
           <p:nvPr/>
         </p:nvSpPr>
@@ -15109,7 +15439,7 @@
       </p:sp>
       <p:sp>
         <p:nvSpPr>
-          <p:cNvPr id="17424" name="Rounded Rectangle 17423"/>
+          <p:cNvPr id="17425" name="Rounded Rectangle 17424"/>
           <p:cNvSpPr/>
           <p:nvPr/>
         </p:nvSpPr>
@@ -15174,7 +15504,7 @@
       </p:sp>
       <p:sp>
         <p:nvSpPr>
-          <p:cNvPr id="17425" name="Down Arrow 17424"/>
+          <p:cNvPr id="17426" name="Down Arrow 17425"/>
           <p:cNvSpPr/>
           <p:nvPr/>
         </p:nvSpPr>
@@ -15218,7 +15548,7 @@
       </p:sp>
       <p:sp>
         <p:nvSpPr>
-          <p:cNvPr id="17426" name="Rounded Rectangle 17425"/>
+          <p:cNvPr id="17427" name="Rounded Rectangle 17426"/>
           <p:cNvSpPr/>
           <p:nvPr/>
         </p:nvSpPr>
@@ -15283,7 +15613,7 @@
       </p:sp>
       <p:sp>
         <p:nvSpPr>
-          <p:cNvPr id="17427" name="Down Arrow 17426"/>
+          <p:cNvPr id="17428" name="Down Arrow 17427"/>
           <p:cNvSpPr/>
           <p:nvPr/>
         </p:nvSpPr>
@@ -15327,7 +15657,7 @@
       </p:sp>
       <p:sp>
         <p:nvSpPr>
-          <p:cNvPr id="17428" name="Rounded Rectangle 17427"/>
+          <p:cNvPr id="17429" name="Rounded Rectangle 17428"/>
           <p:cNvSpPr/>
           <p:nvPr/>
         </p:nvSpPr>
@@ -15392,7 +15722,7 @@
       </p:sp>
       <p:sp>
         <p:nvSpPr>
-          <p:cNvPr id="17429" name="Rounded Rectangle 17428"/>
+          <p:cNvPr id="17430" name="Rounded Rectangle 17429"/>
           <p:cNvSpPr/>
           <p:nvPr/>
         </p:nvSpPr>
@@ -15445,7 +15775,7 @@
       </p:sp>
       <p:sp>
         <p:nvSpPr>
-          <p:cNvPr id="17430" name="Rounded Rectangle 17429"/>
+          <p:cNvPr id="17431" name="Rounded Rectangle 17430"/>
           <p:cNvSpPr/>
           <p:nvPr/>
         </p:nvSpPr>
@@ -15489,7 +15819,7 @@
       </p:sp>
       <p:pic>
         <p:nvPicPr>
-          <p:cNvPr id="17431" name="Picture 17430" descr="dashboard_crop_new.jpg"/>
+          <p:cNvPr id="17432" name="Picture 17431" descr="dashboard_crop_new.jpg"/>
           <p:cNvPicPr>
             <a:picLocks noChangeAspect="1"/>
           </p:cNvPicPr>

</xml_diff>